<commit_message>
docs: close D7 and D10, refresh evidence, testing document, deck, poster and report sources
</commit_message>
<xml_diff>
--- a/docs/Phase_III_IV_EcoMesh_Final.pptx
+++ b/docs/Phase_III_IV_EcoMesh_Final.pptx
@@ -124,7 +124,7 @@
 <c:chartSpace xmlns:c="http://schemas.openxmlformats.org/drawingml/2006/chart" xmlns:a="http://schemas.openxmlformats.org/drawingml/2006/main" xmlns:r="http://schemas.openxmlformats.org/officeDocument/2006/relationships">
   <c:date1904 val="0"/>
   <c:chart>
-    <c:autoTitleDeleted val="0"/>
+    <c:autoTitleDeleted val="1"/>
     <c:plotArea>
       <c:lineChart>
         <c:grouping val="standard"/>
@@ -331,7 +331,7 @@
 <c:chartSpace xmlns:c="http://schemas.openxmlformats.org/drawingml/2006/chart" xmlns:a="http://schemas.openxmlformats.org/drawingml/2006/main" xmlns:r="http://schemas.openxmlformats.org/officeDocument/2006/relationships">
   <c:date1904 val="0"/>
   <c:chart>
-    <c:autoTitleDeleted val="0"/>
+    <c:autoTitleDeleted val="1"/>
     <c:plotArea>
       <c:barChart>
         <c:barDir val="col"/>
@@ -522,7 +522,7 @@
 <c:chartSpace xmlns:c="http://schemas.openxmlformats.org/drawingml/2006/chart" xmlns:a="http://schemas.openxmlformats.org/drawingml/2006/main" xmlns:r="http://schemas.openxmlformats.org/officeDocument/2006/relationships">
   <c:date1904 val="0"/>
   <c:chart>
-    <c:autoTitleDeleted val="0"/>
+    <c:autoTitleDeleted val="1"/>
     <c:plotArea>
       <c:barChart>
         <c:barDir val="col"/>
@@ -1174,7 +1174,7 @@
           <a:lstStyle/>
           <a:p>
             <a:r>
-              <a:t>Functional testing asks whether each feature does what the specification says. A fresh run of the suite just now passed 331 tests in 27 seconds. Our SRS has 68 numbered functional requirements and every one is traced to the test or check that verifies it: 64 are fully verified by automated tests, 12 of them with a manual look at the screen. The remaining 4 are marked partly implemented, verified by inspection or by a manual check, and the testing document says which. We also drive the real device screens in a browser, pressing the buttons a user would press, and record the results.</a:t>
+              <a:t>Functional testing asks whether each feature does what the specification says. A fresh run of the suite just now passed 332 tests in 26 seconds. Our SRS has 68 numbered functional requirements and every one is traced to the test or check that verifies it: 64 are fully verified by automated tests, 12 of them with a manual look at the screen. The remaining 4 are marked partly implemented, verified by inspection or by a manual check, and the testing document says which. We also drive the real device screens in a browser, pressing the buttons a user would press, and record the results.</a:t>
             </a:r>
           </a:p>
         </p:txBody>
@@ -1244,7 +1244,7 @@
           <a:lstStyle/>
           <a:p>
             <a:r>
-              <a:t>Non-functional testing asks how well. We fixed ten targets in the project plan before measuring, and 7 of them are fully met. The left chart shows delivery staying at 100 percent up to 10 percent loss on every link and degrading gracefully after that. The middle chart is the central claim of the routing design: on identical seeds, weighted routing delivered 99.2 percent against 57.4 percent for hop-count routing. The right chart shows that under congestion the median SOS arrives 4.4 times faster than routine traffic. And here are the misses, because we would rather you hear them from us: K2 convergence; K3 recovery after relay death; K9 correctness. Delivery was 92.6% on a 40-node mesh with 20 percent loss and failures; recovery time is limited by the ten-second heartbeat; and at 20 percent loss delivery is 92.9 percent at 50 nodes but 83.1 percent at 65.</a:t>
+              <a:t>Non-functional testing asks how well. We fixed ten targets in the project plan before measuring, and 8 of them are fully met. The left chart shows delivery staying at 100 percent up to 10 percent loss on every link and degrading gracefully after that. The middle chart is the central claim of the routing design: on identical seeds, weighted routing delivered 99.2 percent against 57.4 percent for hop-count routing. The right chart shows that under congestion the median SOS arrives 4.4 times faster than routine traffic. And here are the misses, because we would rather you hear them from us: K2 convergence; K3 recovery after relay death. Delivery was 92.6% on a 40-node mesh with 20 percent loss and failures; recovery time is limited by the ten-second heartbeat; and at 20 percent loss delivery is 92.9 percent at 50 nodes but 83.1 percent at 65.</a:t>
             </a:r>
           </a:p>
         </p:txBody>
@@ -1804,7 +1804,7 @@
           <a:lstStyle/>
           <a:p>
             <a:r>
-              <a:t>Repository and branching. Phase 2 of the college plan asked us to set up the repository and a branching strategy. We use one branch per phase, and each branch inherits everything before it, so a reviewer can check out the branch for Phase 3 and see exactly what existed then. We never merge between phase branches, and main is reserved for tagged releases. The counts on screen are cumulative commits read from git: develop 14, develop_2 16, develop_3 39, develop_4 48, develop_5 56, develop_6 84. We use Conventional Commits; 78 of 84 commits follow the format, and the exceptions are from the first weeks. The commit counts by member are Twissha 31   Miti 31   Tanvi 22.</a:t>
+              <a:t>Repository and branching. Phase 2 of the college plan asked us to set up the repository and a branching strategy. We use one branch per phase, and each branch inherits everything before it, so a reviewer can check out the branch for Phase 3 and see exactly what existed then. We never merge between phase branches, and main is reserved for tagged releases. The counts on screen are cumulative commits read from git: develop 14, develop_2 16, develop_3 39, develop_4 48, develop_5 56, develop_6 95. We use Conventional Commits; 89 of 95 commits follow the format, and the exceptions are from the first weeks. The commit counts by member are Twissha 34   Tanvi 30   Miti 31.</a:t>
             </a:r>
           </a:p>
         </p:txBody>
@@ -1944,7 +1944,7 @@
           <a:lstStyle/>
           <a:p>
             <a:r>
-              <a:t>Integration is where bugs hide that unit tests cannot see. These seven defects were found by wiring things together or by hammering them. D2 is the most important: multi-hop acknowledgements did not work at all, because the duplicate filter dropped every ACK at the first relay its data had crossed, and swallowed retries. D4 was found by fuzzing: random bytes made the parser raise the wrong exception. D6, the two flaky tests, is closed. D7 is open, and we want to be transparent about it: a history test fails occasionally because two messages created in the same millisecond have no defined order. It is open and reported to its owner.</a:t>
+              <a:t>Integration is where bugs hide that unit tests cannot see. These 8 defects were found by wiring things together or by hammering them. D2 is the most important: multi-hop acknowledgements did not work at all, because the duplicate filter dropped every ACK at the first relay its data had crossed, and swallowed retries. D4 was found by fuzzing: random bytes made the parser raise the wrong exception. D6, D7 and D10 are tests that failed now and then under load. We fixed each at its cause, not by retrying: ties in the history are broken by row id, and the attack drill now waits until the destination knows the sender's key instead of sleeping a fixed time. Each passed 30 of 30 runs while the CPU was kept busy.</a:t>
             </a:r>
           </a:p>
         </p:txBody>
@@ -6080,7 +6080,7 @@
                 </a:solidFill>
                 <a:latin typeface="Segoe UI"/>
               </a:rPr>
-              <a:t>331</a:t>
+              <a:t>332</a:t>
             </a:r>
           </a:p>
         </p:txBody>
@@ -6624,7 +6624,7 @@
                 </a:solidFill>
                 <a:latin typeface="Segoe UI"/>
               </a:rPr>
-              <a:t>Non-functional results: 7 of 10 targets fully met</a:t>
+              <a:t>Non-functional results: 8 of 10 targets fully met</a:t>
             </a:r>
           </a:p>
         </p:txBody>
@@ -7178,7 +7178,7 @@
                 </a:solidFill>
                 <a:latin typeface="Segoe UI"/>
               </a:rPr>
-              <a:t>K1, K4, K5, K6, K7, K8, K10.   </a:t>
+              <a:t>K1, K4, K5, K6, K7, K8, K9, K10.   </a:t>
             </a:r>
             <a:r>
               <a:rPr sz="1350" b="1" i="0">
@@ -7196,7 +7196,7 @@
                 </a:solidFill>
                 <a:latin typeface="Segoe UI"/>
               </a:rPr>
-              <a:t>K2 convergence; K3 recovery after relay death; K9 correctness.</a:t>
+              <a:t>K2 convergence; K3 recovery after relay death.</a:t>
             </a:r>
           </a:p>
           <a:p>
@@ -12042,7 +12042,7 @@
                 </a:solidFill>
                 <a:latin typeface="Segoe UI"/>
               </a:rPr>
-              <a:t>Every module has its own test file. The suite has 331 tests in total.</a:t>
+              <a:t>Every module has its own test file. The suite has 332 tests in total.</a:t>
             </a:r>
           </a:p>
         </p:txBody>
@@ -15049,7 +15049,7 @@
                 </a:solidFill>
                 <a:latin typeface="Segoe UI"/>
               </a:rPr>
-              <a:t>84</a:t>
+              <a:t>95</a:t>
             </a:r>
           </a:p>
         </p:txBody>
@@ -15253,7 +15253,7 @@
                 </a:solidFill>
                 <a:latin typeface="Segoe UI"/>
               </a:rPr>
-              <a:t>78 of 84 commits (93%) follow type(scope): description. The 6 that do not are five early commits from Phases 1 and 2 and one merge commit.</a:t>
+              <a:t>89 of 95 commits (94%) follow type(scope): description. The 6 that do not are five early commits from Phases 1 and 2 and one merge commit.</a:t>
             </a:r>
           </a:p>
         </p:txBody>
@@ -15379,7 +15379,7 @@
                 </a:solidFill>
                 <a:latin typeface="Segoe UI"/>
               </a:rPr>
-              <a:t>Commits by member: Twissha 31   Miti 31   Tanvi 22. Commit messages carry the type (feat, fix, test, docs, chore) so the history can be read as a changelog.</a:t>
+              <a:t>Commits by member: Twissha 34   Tanvi 30   Miti 31. Commit messages carry the type (feat, fix, test, docs, chore) so the history can be read as a changelog.</a:t>
             </a:r>
           </a:p>
         </p:txBody>
@@ -16053,7 +16053,7 @@
                 </a:solidFill>
                 <a:latin typeface="Segoe UI"/>
               </a:rPr>
-              <a:t>Seven defects in the engine and tests. Six are closed with a regression test; one is open.</a:t>
+              <a:t>8 defects in the engine and tests, all closed and covered by a regression test.</a:t>
             </a:r>
           </a:p>
         </p:txBody>
@@ -16181,7 +16181,7 @@
         </p:nvGraphicFramePr>
         <p:xfrm>
           <a:off x="548640" y="1783080"/>
-          <a:ext cx="11091670" cy="4242816"/>
+          <a:ext cx="11091670" cy="4279392"/>
         </p:xfrm>
         <a:graphic>
           <a:graphicData uri="http://schemas.openxmlformats.org/drawingml/2006/table">
@@ -16195,7 +16195,7 @@
                 <a:gridCol w="3925447"/>
                 <a:gridCol w="867250"/>
               </a:tblGrid>
-              <a:tr h="530352">
+              <a:tr h="475488">
                 <a:tc>
                   <a:txBody>
                     <a:bodyPr wrap="square"/>
@@ -16285,14 +16285,14 @@
                   </a:tcPr>
                 </a:tc>
               </a:tr>
-              <a:tr h="530352">
+              <a:tr h="475488">
                 <a:tc>
                   <a:txBody>
                     <a:bodyPr wrap="square"/>
                     <a:lstStyle/>
                     <a:p>
                       <a:r>
-                        <a:rPr sz="1250" b="1">
+                        <a:rPr sz="1200" b="1">
                           <a:solidFill>
                             <a:srgbClr val="14181D"/>
                           </a:solidFill>
@@ -16314,7 +16314,7 @@
                     <a:lstStyle/>
                     <a:p>
                       <a:r>
-                        <a:rPr sz="1250" b="0">
+                        <a:rPr sz="1200" b="0">
                           <a:solidFill>
                             <a:srgbClr val="14181D"/>
                           </a:solidFill>
@@ -16336,7 +16336,7 @@
                     <a:lstStyle/>
                     <a:p>
                       <a:r>
-                        <a:rPr sz="1250" b="0">
+                        <a:rPr sz="1200" b="0">
                           <a:solidFill>
                             <a:srgbClr val="14181D"/>
                           </a:solidFill>
@@ -16358,7 +16358,7 @@
                     <a:lstStyle/>
                     <a:p>
                       <a:r>
-                        <a:rPr sz="1250" b="0">
+                        <a:rPr sz="1200" b="0">
                           <a:solidFill>
                             <a:srgbClr val="14181D"/>
                           </a:solidFill>
@@ -16375,14 +16375,14 @@
                   </a:tcPr>
                 </a:tc>
               </a:tr>
-              <a:tr h="530352">
+              <a:tr h="475488">
                 <a:tc>
                   <a:txBody>
                     <a:bodyPr wrap="square"/>
                     <a:lstStyle/>
                     <a:p>
                       <a:r>
-                        <a:rPr sz="1250" b="1">
+                        <a:rPr sz="1200" b="1">
                           <a:solidFill>
                             <a:srgbClr val="14181D"/>
                           </a:solidFill>
@@ -16404,7 +16404,7 @@
                     <a:lstStyle/>
                     <a:p>
                       <a:r>
-                        <a:rPr sz="1250" b="0">
+                        <a:rPr sz="1200" b="0">
                           <a:solidFill>
                             <a:srgbClr val="14181D"/>
                           </a:solidFill>
@@ -16426,7 +16426,7 @@
                     <a:lstStyle/>
                     <a:p>
                       <a:r>
-                        <a:rPr sz="1250" b="0">
+                        <a:rPr sz="1200" b="0">
                           <a:solidFill>
                             <a:srgbClr val="14181D"/>
                           </a:solidFill>
@@ -16448,7 +16448,7 @@
                     <a:lstStyle/>
                     <a:p>
                       <a:r>
-                        <a:rPr sz="1250" b="0">
+                        <a:rPr sz="1200" b="0">
                           <a:solidFill>
                             <a:srgbClr val="14181D"/>
                           </a:solidFill>
@@ -16465,14 +16465,14 @@
                   </a:tcPr>
                 </a:tc>
               </a:tr>
-              <a:tr h="530352">
+              <a:tr h="475488">
                 <a:tc>
                   <a:txBody>
                     <a:bodyPr wrap="square"/>
                     <a:lstStyle/>
                     <a:p>
                       <a:r>
-                        <a:rPr sz="1250" b="1">
+                        <a:rPr sz="1200" b="1">
                           <a:solidFill>
                             <a:srgbClr val="14181D"/>
                           </a:solidFill>
@@ -16494,7 +16494,7 @@
                     <a:lstStyle/>
                     <a:p>
                       <a:r>
-                        <a:rPr sz="1250" b="0">
+                        <a:rPr sz="1200" b="0">
                           <a:solidFill>
                             <a:srgbClr val="14181D"/>
                           </a:solidFill>
@@ -16516,7 +16516,7 @@
                     <a:lstStyle/>
                     <a:p>
                       <a:r>
-                        <a:rPr sz="1250" b="0">
+                        <a:rPr sz="1200" b="0">
                           <a:solidFill>
                             <a:srgbClr val="14181D"/>
                           </a:solidFill>
@@ -16538,7 +16538,7 @@
                     <a:lstStyle/>
                     <a:p>
                       <a:r>
-                        <a:rPr sz="1250" b="0">
+                        <a:rPr sz="1200" b="0">
                           <a:solidFill>
                             <a:srgbClr val="14181D"/>
                           </a:solidFill>
@@ -16555,14 +16555,14 @@
                   </a:tcPr>
                 </a:tc>
               </a:tr>
-              <a:tr h="530352">
+              <a:tr h="475488">
                 <a:tc>
                   <a:txBody>
                     <a:bodyPr wrap="square"/>
                     <a:lstStyle/>
                     <a:p>
                       <a:r>
-                        <a:rPr sz="1250" b="1">
+                        <a:rPr sz="1200" b="1">
                           <a:solidFill>
                             <a:srgbClr val="14181D"/>
                           </a:solidFill>
@@ -16584,7 +16584,7 @@
                     <a:lstStyle/>
                     <a:p>
                       <a:r>
-                        <a:rPr sz="1250" b="0">
+                        <a:rPr sz="1200" b="0">
                           <a:solidFill>
                             <a:srgbClr val="14181D"/>
                           </a:solidFill>
@@ -16606,7 +16606,7 @@
                     <a:lstStyle/>
                     <a:p>
                       <a:r>
-                        <a:rPr sz="1250" b="0">
+                        <a:rPr sz="1200" b="0">
                           <a:solidFill>
                             <a:srgbClr val="14181D"/>
                           </a:solidFill>
@@ -16628,7 +16628,7 @@
                     <a:lstStyle/>
                     <a:p>
                       <a:r>
-                        <a:rPr sz="1250" b="0">
+                        <a:rPr sz="1200" b="0">
                           <a:solidFill>
                             <a:srgbClr val="14181D"/>
                           </a:solidFill>
@@ -16645,14 +16645,14 @@
                   </a:tcPr>
                 </a:tc>
               </a:tr>
-              <a:tr h="530352">
+              <a:tr h="475488">
                 <a:tc>
                   <a:txBody>
                     <a:bodyPr wrap="square"/>
                     <a:lstStyle/>
                     <a:p>
                       <a:r>
-                        <a:rPr sz="1250" b="1">
+                        <a:rPr sz="1200" b="1">
                           <a:solidFill>
                             <a:srgbClr val="14181D"/>
                           </a:solidFill>
@@ -16674,7 +16674,7 @@
                     <a:lstStyle/>
                     <a:p>
                       <a:r>
-                        <a:rPr sz="1250" b="0">
+                        <a:rPr sz="1200" b="0">
                           <a:solidFill>
                             <a:srgbClr val="14181D"/>
                           </a:solidFill>
@@ -16696,7 +16696,7 @@
                     <a:lstStyle/>
                     <a:p>
                       <a:r>
-                        <a:rPr sz="1250" b="0">
+                        <a:rPr sz="1200" b="0">
                           <a:solidFill>
                             <a:srgbClr val="14181D"/>
                           </a:solidFill>
@@ -16718,7 +16718,7 @@
                     <a:lstStyle/>
                     <a:p>
                       <a:r>
-                        <a:rPr sz="1250" b="0">
+                        <a:rPr sz="1200" b="0">
                           <a:solidFill>
                             <a:srgbClr val="14181D"/>
                           </a:solidFill>
@@ -16735,14 +16735,14 @@
                   </a:tcPr>
                 </a:tc>
               </a:tr>
-              <a:tr h="530352">
+              <a:tr h="475488">
                 <a:tc>
                   <a:txBody>
                     <a:bodyPr wrap="square"/>
                     <a:lstStyle/>
                     <a:p>
                       <a:r>
-                        <a:rPr sz="1250" b="1">
+                        <a:rPr sz="1200" b="1">
                           <a:solidFill>
                             <a:srgbClr val="14181D"/>
                           </a:solidFill>
@@ -16764,7 +16764,7 @@
                     <a:lstStyle/>
                     <a:p>
                       <a:r>
-                        <a:rPr sz="1250" b="0">
+                        <a:rPr sz="1200" b="0">
                           <a:solidFill>
                             <a:srgbClr val="14181D"/>
                           </a:solidFill>
@@ -16786,7 +16786,7 @@
                     <a:lstStyle/>
                     <a:p>
                       <a:r>
-                        <a:rPr sz="1250" b="0">
+                        <a:rPr sz="1200" b="0">
                           <a:solidFill>
                             <a:srgbClr val="14181D"/>
                           </a:solidFill>
@@ -16808,7 +16808,7 @@
                     <a:lstStyle/>
                     <a:p>
                       <a:r>
-                        <a:rPr sz="1250" b="0">
+                        <a:rPr sz="1200" b="0">
                           <a:solidFill>
                             <a:srgbClr val="14181D"/>
                           </a:solidFill>
@@ -16825,14 +16825,14 @@
                   </a:tcPr>
                 </a:tc>
               </a:tr>
-              <a:tr h="530352">
+              <a:tr h="475488">
                 <a:tc>
                   <a:txBody>
                     <a:bodyPr wrap="square"/>
                     <a:lstStyle/>
                     <a:p>
                       <a:r>
-                        <a:rPr sz="1250" b="1">
+                        <a:rPr sz="1200" b="1">
                           <a:solidFill>
                             <a:srgbClr val="14181D"/>
                           </a:solidFill>
@@ -16854,13 +16854,13 @@
                     <a:lstStyle/>
                     <a:p>
                       <a:r>
-                        <a:rPr sz="1250" b="0">
+                        <a:rPr sz="1200" b="0">
                           <a:solidFill>
                             <a:srgbClr val="14181D"/>
                           </a:solidFill>
                           <a:latin typeface="Segoe UI"/>
                         </a:rPr>
-                        <a:t>History-order test fails now and then: same-millisecond messages have no order</a:t>
+                        <a:t>History test failed now and then: same-millisecond messages had no order</a:t>
                       </a:r>
                     </a:p>
                   </a:txBody>
@@ -16876,13 +16876,13 @@
                     <a:lstStyle/>
                     <a:p>
                       <a:r>
-                        <a:rPr sz="1250" b="0">
+                        <a:rPr sz="1200" b="0">
                           <a:solidFill>
                             <a:srgbClr val="14181D"/>
                           </a:solidFill>
                           <a:latin typeface="Segoe UI"/>
                         </a:rPr>
-                        <a:t>Add a second sort key; with the test's owner</a:t>
+                        <a:t>Ties broken by row id; regression test added</a:t>
                       </a:r>
                     </a:p>
                   </a:txBody>
@@ -16898,19 +16898,109 @@
                     <a:lstStyle/>
                     <a:p>
                       <a:r>
-                        <a:rPr sz="1250" b="0">
+                        <a:rPr sz="1200" b="0">
                           <a:solidFill>
                             <a:srgbClr val="14181D"/>
                           </a:solidFill>
                           <a:latin typeface="Segoe UI"/>
                         </a:rPr>
-                        <a:t>Open</a:t>
+                        <a:t>Closed</a:t>
                       </a:r>
                     </a:p>
                   </a:txBody>
                   <a:tcPr marL="91440" marR="91440" marT="36576" marB="36576" anchor="ctr">
                     <a:solidFill>
                       <a:srgbClr val="F3F5F8"/>
+                    </a:solidFill>
+                  </a:tcPr>
+                </a:tc>
+              </a:tr>
+              <a:tr h="475488">
+                <a:tc>
+                  <a:txBody>
+                    <a:bodyPr wrap="square"/>
+                    <a:lstStyle/>
+                    <a:p>
+                      <a:r>
+                        <a:rPr sz="1200" b="1">
+                          <a:solidFill>
+                            <a:srgbClr val="14181D"/>
+                          </a:solidFill>
+                          <a:latin typeface="Segoe UI"/>
+                        </a:rPr>
+                        <a:t>D10</a:t>
+                      </a:r>
+                    </a:p>
+                  </a:txBody>
+                  <a:tcPr marL="91440" marR="91440" marT="36576" marB="36576" anchor="ctr">
+                    <a:solidFill>
+                      <a:srgbClr val="FFFFFF"/>
+                    </a:solidFill>
+                  </a:tcPr>
+                </a:tc>
+                <a:tc>
+                  <a:txBody>
+                    <a:bodyPr wrap="square"/>
+                    <a:lstStyle/>
+                    <a:p>
+                      <a:r>
+                        <a:rPr sz="1200" b="0">
+                          <a:solidFill>
+                            <a:srgbClr val="14181D"/>
+                          </a:solidFill>
+                          <a:latin typeface="Segoe UI"/>
+                        </a:rPr>
+                        <a:t>Attack-drill test failed under load: fixed waits gave a wrong verdict</a:t>
+                      </a:r>
+                    </a:p>
+                  </a:txBody>
+                  <a:tcPr marL="91440" marR="91440" marT="36576" marB="36576" anchor="ctr">
+                    <a:solidFill>
+                      <a:srgbClr val="FFFFFF"/>
+                    </a:solidFill>
+                  </a:tcPr>
+                </a:tc>
+                <a:tc>
+                  <a:txBody>
+                    <a:bodyPr wrap="square"/>
+                    <a:lstStyle/>
+                    <a:p>
+                      <a:r>
+                        <a:rPr sz="1200" b="0">
+                          <a:solidFill>
+                            <a:srgbClr val="14181D"/>
+                          </a:solidFill>
+                          <a:latin typeface="Segoe UI"/>
+                        </a:rPr>
+                        <a:t>Drill polls for its conditions; 30 of 30 runs pass under load</a:t>
+                      </a:r>
+                    </a:p>
+                  </a:txBody>
+                  <a:tcPr marL="91440" marR="91440" marT="36576" marB="36576" anchor="ctr">
+                    <a:solidFill>
+                      <a:srgbClr val="FFFFFF"/>
+                    </a:solidFill>
+                  </a:tcPr>
+                </a:tc>
+                <a:tc>
+                  <a:txBody>
+                    <a:bodyPr wrap="square"/>
+                    <a:lstStyle/>
+                    <a:p>
+                      <a:r>
+                        <a:rPr sz="1200" b="0">
+                          <a:solidFill>
+                            <a:srgbClr val="14181D"/>
+                          </a:solidFill>
+                          <a:latin typeface="Segoe UI"/>
+                        </a:rPr>
+                        <a:t>Closed</a:t>
+                      </a:r>
+                    </a:p>
+                  </a:txBody>
+                  <a:tcPr marL="91440" marR="91440" marT="36576" marB="36576" anchor="ctr">
+                    <a:solidFill>
+                      <a:srgbClr val="FFFFFF"/>
                     </a:solidFill>
                   </a:tcPr>
                 </a:tc>

</xml_diff>

<commit_message>
docs(report): rebuild the report with the final numbers, close D7 and D10, compact the appendix
</commit_message>
<xml_diff>
--- a/docs/Phase_III_IV_EcoMesh_Final.pptx
+++ b/docs/Phase_III_IV_EcoMesh_Final.pptx
@@ -1804,7 +1804,7 @@
           <a:lstStyle/>
           <a:p>
             <a:r>
-              <a:t>Repository and branching. Phase 2 of the college plan asked us to set up the repository and a branching strategy. We use one branch per phase, and each branch inherits everything before it, so a reviewer can check out the branch for Phase 3 and see exactly what existed then. We never merge between phase branches, and main is reserved for tagged releases. The counts on screen are cumulative commits read from git: develop 14, develop_2 16, develop_3 39, develop_4 48, develop_5 56, develop_6 95. We use Conventional Commits; 89 of 95 commits follow the format, and the exceptions are from the first weeks. The commit counts by member are Twissha 34   Tanvi 30   Miti 31.</a:t>
+              <a:t>Repository and branching. Phase 2 of the college plan asked us to set up the repository and a branching strategy. We use one branch per phase, and each branch inherits everything before it, so a reviewer can check out the branch for Phase 3 and see exactly what existed then. We never merge between phase branches, and main is reserved for tagged releases. The counts on screen are cumulative commits read from git: develop 14, develop_2 16, develop_3 39, develop_4 48, develop_5 56, develop_6 96. We use Conventional Commits; 90 of 96 commits follow the format, and the exceptions are from the first weeks. The commit counts by member are Twissha 35   Tanvi 30   Miti 31.</a:t>
             </a:r>
           </a:p>
         </p:txBody>
@@ -15049,7 +15049,7 @@
                 </a:solidFill>
                 <a:latin typeface="Segoe UI"/>
               </a:rPr>
-              <a:t>95</a:t>
+              <a:t>96</a:t>
             </a:r>
           </a:p>
         </p:txBody>
@@ -15253,7 +15253,7 @@
                 </a:solidFill>
                 <a:latin typeface="Segoe UI"/>
               </a:rPr>
-              <a:t>89 of 95 commits (94%) follow type(scope): description. The 6 that do not are five early commits from Phases 1 and 2 and one merge commit.</a:t>
+              <a:t>90 of 96 commits (94%) follow type(scope): description. The 6 that do not are five early commits from Phases 1 and 2 and one merge commit.</a:t>
             </a:r>
           </a:p>
         </p:txBody>
@@ -15379,7 +15379,7 @@
                 </a:solidFill>
                 <a:latin typeface="Segoe UI"/>
               </a:rPr>
-              <a:t>Commits by member: Twissha 34   Tanvi 30   Miti 31. Commit messages carry the type (feat, fix, test, docs, chore) so the history can be read as a changelog.</a:t>
+              <a:t>Commits by member: Twissha 35   Tanvi 30   Miti 31. Commit messages carry the type (feat, fix, test, docs, chore) so the history can be read as a changelog.</a:t>
             </a:r>
           </a:p>
         </p:txBody>

</xml_diff>